<commit_message>
little adjustments to the presentation
</commit_message>
<xml_diff>
--- a/presentation/Bank Marketing Who Subscribes.pptx
+++ b/presentation/Bank Marketing Who Subscribes.pptx
@@ -9142,7 +9142,7 @@
         <p:spPr>
           <a:xfrm>
             <a:off x="812800" y="4356100"/>
-            <a:ext cx="10883392" cy="774700"/>
+            <a:ext cx="10883392" cy="777240"/>
           </a:xfrm>
           <a:prstGeom prst="rect">
             <a:avLst/>
@@ -9216,6 +9216,50 @@
                 <a:cs typeface="Arial" pitchFamily="34" charset="-120"/>
               </a:rPr>
               <a:t>. Calling everyone: 100% of the calls, and 89% of them are wasted.</a:t>
+            </a:r>
+            <a:endParaRPr lang="en-US" sz="2200" dirty="0"/>
+          </a:p>
+        </p:txBody>
+      </p:sp>
+      <p:sp>
+        <p:nvSpPr>
+          <p:cNvPr id="16" name="Text 14"/>
+          <p:cNvSpPr/>
+          <p:nvPr/>
+        </p:nvSpPr>
+        <p:spPr>
+          <a:xfrm>
+            <a:off x="812800" y="5349240"/>
+            <a:ext cx="10883392" cy="685800"/>
+          </a:xfrm>
+          <a:prstGeom prst="rect">
+            <a:avLst/>
+          </a:prstGeom>
+          <a:noFill/>
+          <a:ln/>
+        </p:spPr>
+        <p:txBody>
+          <a:bodyPr wrap="square" lIns="0" tIns="0" rIns="0" bIns="0" rtlCol="0" anchor="t">
+            <a:normAutofit/>
+          </a:bodyPr>
+          <a:lstStyle/>
+          <a:p>
+            <a:pPr algn="l" indent="0" marL="0">
+              <a:lnSpc>
+                <a:spcPts val="2970"/>
+              </a:lnSpc>
+              <a:buNone/>
+            </a:pPr>
+            <a:r>
+              <a:rPr lang="en-US" sz="1600" dirty="0">
+                <a:solidFill>
+                  <a:srgbClr val="555555"/>
+                </a:solidFill>
+                <a:latin typeface="Arial" pitchFamily="34" charset="0"/>
+                <a:ea typeface="Arial" pitchFamily="34" charset="-122"/>
+                <a:cs typeface="Arial" pitchFamily="34" charset="-120"/>
+              </a:rPr>
+              <a:t>How: the test set has 8,236 clients, 928 of them subscribers. The model calls 1,248 of them (15%), and 565 of those subscribe: 565 / 928 = 61%. Calling everyone, only 11.3% say yes, so 89% of the calls are wasted.</a:t>
             </a:r>
             <a:endParaRPr lang="en-US" sz="2200" dirty="0"/>
           </a:p>

</xml_diff>